<commit_message>
Added new distro recipes
</commit_message>
<xml_diff>
--- a/yocto_training_all_session_decks/session_decks/D4S2_Boot_Flash_Verify.pptx
+++ b/yocto_training_all_session_decks/session_decks/D4S2_Boot_Flash_Verify.pptx
@@ -2929,7 +2929,7 @@
           <a:p>
             <a:fld id="{0CEC647C-F50C-4F78-AA33-D7AA6CDA18EE}" type="datetimeFigureOut">
               <a:rPr lang="en-US" smtClean="0"/>
-              <a:t>6/11/2026</a:t>
+              <a:t>6/12/2026</a:t>
             </a:fld>
             <a:endParaRPr lang="en-US"/>
           </a:p>
@@ -3094,7 +3094,7 @@
           <a:p>
             <a:fld id="{3A83341F-E62C-483B-84B4-966F8BE46097}" type="datetimeFigureOut">
               <a:rPr lang="en-US" smtClean="0"/>
-              <a:t>6/11/2026</a:t>
+              <a:t>6/12/2026</a:t>
             </a:fld>
             <a:endParaRPr lang="en-US"/>
           </a:p>
@@ -5299,10 +5299,7 @@
           <a:lstStyle/>
           <a:p>
             <a:r>
-              <a:rPr sz="3200" b="1">
-                <a:solidFill>
-                  <a:srgbClr val="CC0066"/>
-                </a:solidFill>
+              <a:rPr sz="3200" b="1" dirty="0">
                 <a:latin typeface="Calibri"/>
               </a:rPr>
               <a:t>Session Agenda</a:t>
@@ -5454,10 +5451,7 @@
           <a:lstStyle/>
           <a:p>
             <a:r>
-              <a:rPr sz="3200" b="1">
-                <a:solidFill>
-                  <a:srgbClr val="CC0066"/>
-                </a:solidFill>
+              <a:rPr sz="3200" b="1" dirty="0">
                 <a:latin typeface="Calibri"/>
               </a:rPr>
               <a:t>Boot Flow on a Real Device</a:t>
@@ -6229,7 +6223,7 @@
         <p:spPr>
           <a:xfrm>
             <a:off x="822960" y="3657600"/>
-            <a:ext cx="10515600" cy="2377440"/>
+            <a:ext cx="10515600" cy="2231380"/>
           </a:xfrm>
           <a:prstGeom prst="rect">
             <a:avLst/>
@@ -6248,7 +6242,7 @@
               </a:spcAft>
             </a:pPr>
             <a:r>
-              <a:rPr sz="1500" b="1" i="0">
+              <a:rPr b="1" i="0" dirty="0">
                 <a:solidFill>
                   <a:srgbClr val="CC0066"/>
                 </a:solidFill>
@@ -6264,13 +6258,31 @@
               </a:spcAft>
             </a:pPr>
             <a:r>
-              <a:rPr sz="1200" b="0" i="0">
+              <a:rPr sz="1600" b="0" i="0" dirty="0">
                 <a:solidFill>
                   <a:srgbClr val="333333"/>
                 </a:solidFill>
                 <a:latin typeface="Calibri"/>
               </a:rPr>
-              <a:t>• Vendor ROM (BootROM): vendor's first-stage; usually unmodifiable</a:t>
+              <a:t>• Vendor ROM (</a:t>
+            </a:r>
+            <a:r>
+              <a:rPr sz="1600" b="0" i="0" dirty="0" err="1">
+                <a:solidFill>
+                  <a:srgbClr val="333333"/>
+                </a:solidFill>
+                <a:latin typeface="Calibri"/>
+              </a:rPr>
+              <a:t>BootROM</a:t>
+            </a:r>
+            <a:r>
+              <a:rPr sz="1600" b="0" i="0" dirty="0">
+                <a:solidFill>
+                  <a:srgbClr val="333333"/>
+                </a:solidFill>
+                <a:latin typeface="Calibri"/>
+              </a:rPr>
+              <a:t>): vendor's first-stage; usually unmodifiable</a:t>
             </a:r>
           </a:p>
           <a:p>
@@ -6280,7 +6292,7 @@
               </a:spcAft>
             </a:pPr>
             <a:r>
-              <a:rPr sz="1200" b="0" i="0">
+              <a:rPr sz="1600" b="0" i="0" dirty="0">
                 <a:solidFill>
                   <a:srgbClr val="333333"/>
                 </a:solidFill>
@@ -6296,14 +6308,47 @@
               </a:spcAft>
             </a:pPr>
             <a:r>
-              <a:rPr sz="1200" b="0" i="0">
+              <a:rPr sz="1600" b="0" i="0" dirty="0">
                 <a:solidFill>
                   <a:srgbClr val="333333"/>
                 </a:solidFill>
                 <a:latin typeface="Calibri"/>
               </a:rPr>
-              <a:t>• U-Boot: loads kernel + DTB + initramfs; passes bootargs</a:t>
-            </a:r>
+              <a:t>• U-Boot: loads kernel + DTB + </a:t>
+            </a:r>
+            <a:r>
+              <a:rPr sz="1600" b="0" i="0" dirty="0" err="1">
+                <a:solidFill>
+                  <a:srgbClr val="333333"/>
+                </a:solidFill>
+                <a:latin typeface="Calibri"/>
+              </a:rPr>
+              <a:t>initramfs</a:t>
+            </a:r>
+            <a:r>
+              <a:rPr sz="1600" b="0" i="0" dirty="0">
+                <a:solidFill>
+                  <a:srgbClr val="333333"/>
+                </a:solidFill>
+                <a:latin typeface="Calibri"/>
+              </a:rPr>
+              <a:t>; passes </a:t>
+            </a:r>
+            <a:r>
+              <a:rPr sz="1600" b="0" i="0" dirty="0" err="1">
+                <a:solidFill>
+                  <a:srgbClr val="333333"/>
+                </a:solidFill>
+                <a:latin typeface="Calibri"/>
+              </a:rPr>
+              <a:t>bootargs</a:t>
+            </a:r>
+            <a:endParaRPr sz="1600" b="0" i="0" dirty="0">
+              <a:solidFill>
+                <a:srgbClr val="333333"/>
+              </a:solidFill>
+              <a:latin typeface="Calibri"/>
+            </a:endParaRPr>
           </a:p>
           <a:p>
             <a:pPr>
@@ -6312,7 +6357,7 @@
               </a:spcAft>
             </a:pPr>
             <a:r>
-              <a:rPr sz="1200" b="0" i="0">
+              <a:rPr sz="1600" b="0" i="0" dirty="0">
                 <a:solidFill>
                   <a:srgbClr val="333333"/>
                 </a:solidFill>
@@ -6328,13 +6373,31 @@
               </a:spcAft>
             </a:pPr>
             <a:r>
-              <a:rPr sz="1200" b="0" i="0">
+              <a:rPr sz="1600" b="0" i="0" dirty="0">
                 <a:solidFill>
                   <a:srgbClr val="333333"/>
                 </a:solidFill>
                 <a:latin typeface="Calibri"/>
               </a:rPr>
-              <a:t>• systemd: starts services per unit dependencies</a:t>
+              <a:t>• </a:t>
+            </a:r>
+            <a:r>
+              <a:rPr sz="1600" b="0" i="0" dirty="0" err="1">
+                <a:solidFill>
+                  <a:srgbClr val="333333"/>
+                </a:solidFill>
+                <a:latin typeface="Calibri"/>
+              </a:rPr>
+              <a:t>systemd</a:t>
+            </a:r>
+            <a:r>
+              <a:rPr sz="1600" b="0" i="0" dirty="0">
+                <a:solidFill>
+                  <a:srgbClr val="333333"/>
+                </a:solidFill>
+                <a:latin typeface="Calibri"/>
+              </a:rPr>
+              <a:t>: starts services per unit dependencies</a:t>
             </a:r>
           </a:p>
           <a:p>
@@ -6344,7 +6407,7 @@
               </a:spcAft>
             </a:pPr>
             <a:r>
-              <a:rPr sz="1300" b="1" i="0">
+              <a:rPr sz="1600" b="1" i="0" dirty="0">
                 <a:solidFill>
                   <a:srgbClr val="663399"/>
                 </a:solidFill>
@@ -6396,10 +6459,7 @@
           <a:lstStyle/>
           <a:p>
             <a:r>
-              <a:rPr sz="3200" b="1">
-                <a:solidFill>
-                  <a:srgbClr val="CC0066"/>
-                </a:solidFill>
+              <a:rPr sz="3200" b="1" dirty="0">
                 <a:latin typeface="Calibri"/>
               </a:rPr>
               <a:t>Flashing Methods</a:t>
@@ -6562,7 +6622,7 @@
         <p:spPr>
           <a:xfrm>
             <a:off x="731519" y="2514600"/>
-            <a:ext cx="3337560" cy="3474720"/>
+            <a:ext cx="3337560" cy="3036729"/>
           </a:xfrm>
           <a:prstGeom prst="rect">
             <a:avLst/>
@@ -6581,7 +6641,7 @@
               </a:spcAft>
             </a:pPr>
             <a:r>
-              <a:rPr sz="1200" b="1" i="0">
+              <a:rPr sz="1600" b="1" i="0">
                 <a:solidFill>
                   <a:srgbClr val="CC0066"/>
                 </a:solidFill>
@@ -6597,7 +6657,7 @@
               </a:spcAft>
             </a:pPr>
             <a:r>
-              <a:rPr sz="1100" b="0" i="0">
+              <a:rPr sz="1400" b="0" i="0">
                 <a:solidFill>
                   <a:srgbClr val="333333"/>
                 </a:solidFill>
@@ -6613,7 +6673,7 @@
               </a:spcAft>
             </a:pPr>
             <a:r>
-              <a:rPr sz="1100" b="0" i="0">
+              <a:rPr sz="1400" b="0" i="0">
                 <a:solidFill>
                   <a:srgbClr val="333333"/>
                 </a:solidFill>
@@ -6628,7 +6688,7 @@
                 <a:spcPts val="400"/>
               </a:spcAft>
             </a:pPr>
-            <a:endParaRPr sz="1100" b="0" i="0">
+            <a:endParaRPr sz="1400" b="0" i="0">
               <a:solidFill>
                 <a:srgbClr val="333333"/>
               </a:solidFill>
@@ -6642,7 +6702,7 @@
               </a:spcAft>
             </a:pPr>
             <a:r>
-              <a:rPr sz="1100" b="0" i="0">
+              <a:rPr sz="1400" b="0" i="0">
                 <a:solidFill>
                   <a:srgbClr val="333333"/>
                 </a:solidFill>
@@ -6657,7 +6717,7 @@
                 <a:spcPts val="400"/>
               </a:spcAft>
             </a:pPr>
-            <a:endParaRPr sz="1100" b="0" i="0">
+            <a:endParaRPr sz="1400" b="0" i="0">
               <a:solidFill>
                 <a:srgbClr val="333333"/>
               </a:solidFill>
@@ -6671,7 +6731,7 @@
               </a:spcAft>
             </a:pPr>
             <a:r>
-              <a:rPr sz="1200" b="1" i="0">
+              <a:rPr sz="1600" b="1" i="0">
                 <a:solidFill>
                   <a:srgbClr val="CC0066"/>
                 </a:solidFill>
@@ -6687,7 +6747,7 @@
               </a:spcAft>
             </a:pPr>
             <a:r>
-              <a:rPr sz="1100" b="0" i="0">
+              <a:rPr sz="1400" b="0" i="0">
                 <a:solidFill>
                   <a:srgbClr val="333333"/>
                 </a:solidFill>
@@ -6703,7 +6763,7 @@
               </a:spcAft>
             </a:pPr>
             <a:r>
-              <a:rPr sz="1100" b="0" i="0">
+              <a:rPr sz="1400" b="0" i="0">
                 <a:solidFill>
                   <a:srgbClr val="333333"/>
                 </a:solidFill>
@@ -6718,7 +6778,7 @@
                 <a:spcPts val="400"/>
               </a:spcAft>
             </a:pPr>
-            <a:endParaRPr sz="1100" b="0" i="0">
+            <a:endParaRPr sz="1400" b="0" i="0">
               <a:solidFill>
                 <a:srgbClr val="333333"/>
               </a:solidFill>
@@ -6732,7 +6792,7 @@
               </a:spcAft>
             </a:pPr>
             <a:r>
-              <a:rPr sz="1100" b="0" i="0">
+              <a:rPr sz="1400" b="0" i="0">
                 <a:solidFill>
                   <a:srgbClr val="333333"/>
                 </a:solidFill>
@@ -6863,7 +6923,7 @@
         <p:spPr>
           <a:xfrm>
             <a:off x="4389120" y="2514600"/>
-            <a:ext cx="3337560" cy="3474720"/>
+            <a:ext cx="3337560" cy="3303468"/>
           </a:xfrm>
           <a:prstGeom prst="rect">
             <a:avLst/>
@@ -6882,7 +6942,7 @@
               </a:spcAft>
             </a:pPr>
             <a:r>
-              <a:rPr sz="1200" b="1" i="0">
+              <a:rPr sz="1600" b="1" i="0">
                 <a:solidFill>
                   <a:srgbClr val="663399"/>
                 </a:solidFill>
@@ -6898,7 +6958,7 @@
               </a:spcAft>
             </a:pPr>
             <a:r>
-              <a:rPr sz="1100" b="0" i="0">
+              <a:rPr sz="1400" b="0" i="0">
                 <a:solidFill>
                   <a:srgbClr val="333333"/>
                 </a:solidFill>
@@ -6913,7 +6973,7 @@
                 <a:spcPts val="400"/>
               </a:spcAft>
             </a:pPr>
-            <a:endParaRPr sz="1100" b="0" i="0">
+            <a:endParaRPr sz="1400" b="0" i="0">
               <a:solidFill>
                 <a:srgbClr val="333333"/>
               </a:solidFill>
@@ -6927,7 +6987,7 @@
               </a:spcAft>
             </a:pPr>
             <a:r>
-              <a:rPr sz="1100" b="0" i="0">
+              <a:rPr sz="1400" b="0" i="0">
                 <a:solidFill>
                   <a:srgbClr val="333333"/>
                 </a:solidFill>
@@ -6943,7 +7003,7 @@
               </a:spcAft>
             </a:pPr>
             <a:r>
-              <a:rPr sz="1100" b="0" i="0">
+              <a:rPr sz="1400" b="0" i="0">
                 <a:solidFill>
                   <a:srgbClr val="333333"/>
                 </a:solidFill>
@@ -6958,7 +7018,7 @@
                 <a:spcPts val="400"/>
               </a:spcAft>
             </a:pPr>
-            <a:endParaRPr sz="1100" b="0" i="0">
+            <a:endParaRPr sz="1400" b="0" i="0">
               <a:solidFill>
                 <a:srgbClr val="333333"/>
               </a:solidFill>
@@ -6972,7 +7032,7 @@
               </a:spcAft>
             </a:pPr>
             <a:r>
-              <a:rPr sz="1200" b="1" i="0">
+              <a:rPr sz="1600" b="1" i="0">
                 <a:solidFill>
                   <a:srgbClr val="663399"/>
                 </a:solidFill>
@@ -6988,7 +7048,7 @@
               </a:spcAft>
             </a:pPr>
             <a:r>
-              <a:rPr sz="1100" b="0" i="0">
+              <a:rPr sz="1400" b="0" i="0">
                 <a:solidFill>
                   <a:srgbClr val="333333"/>
                 </a:solidFill>
@@ -7004,7 +7064,7 @@
               </a:spcAft>
             </a:pPr>
             <a:r>
-              <a:rPr sz="1100" b="0" i="0">
+              <a:rPr sz="1400" b="0" i="0">
                 <a:solidFill>
                   <a:srgbClr val="333333"/>
                 </a:solidFill>
@@ -7020,7 +7080,7 @@
               </a:spcAft>
             </a:pPr>
             <a:r>
-              <a:rPr sz="1100" b="0" i="0">
+              <a:rPr sz="1400" b="0" i="0">
                 <a:solidFill>
                   <a:srgbClr val="333333"/>
                 </a:solidFill>
@@ -7035,7 +7095,7 @@
                 <a:spcPts val="400"/>
               </a:spcAft>
             </a:pPr>
-            <a:endParaRPr sz="1100" b="0" i="0">
+            <a:endParaRPr sz="1400" b="0" i="0">
               <a:solidFill>
                 <a:srgbClr val="333333"/>
               </a:solidFill>
@@ -7049,7 +7109,7 @@
               </a:spcAft>
             </a:pPr>
             <a:r>
-              <a:rPr sz="1100" b="0" i="0">
+              <a:rPr sz="1400" b="0" i="0">
                 <a:solidFill>
                   <a:srgbClr val="333333"/>
                 </a:solidFill>
@@ -7180,7 +7240,7 @@
         <p:spPr>
           <a:xfrm>
             <a:off x="8046719" y="2514600"/>
-            <a:ext cx="3337560" cy="3474720"/>
+            <a:ext cx="3337560" cy="3036729"/>
           </a:xfrm>
           <a:prstGeom prst="rect">
             <a:avLst/>
@@ -7199,7 +7259,7 @@
               </a:spcAft>
             </a:pPr>
             <a:r>
-              <a:rPr sz="1200" b="1" i="0">
+              <a:rPr sz="1600" b="1" i="0">
                 <a:solidFill>
                   <a:srgbClr val="CC0066"/>
                 </a:solidFill>
@@ -7215,7 +7275,7 @@
               </a:spcAft>
             </a:pPr>
             <a:r>
-              <a:rPr sz="1100" b="0" i="0">
+              <a:rPr sz="1400" b="0" i="0">
                 <a:solidFill>
                   <a:srgbClr val="333333"/>
                 </a:solidFill>
@@ -7231,7 +7291,7 @@
               </a:spcAft>
             </a:pPr>
             <a:r>
-              <a:rPr sz="1100" b="0" i="0">
+              <a:rPr sz="1400" b="0" i="0">
                 <a:solidFill>
                   <a:srgbClr val="333333"/>
                 </a:solidFill>
@@ -7246,7 +7306,7 @@
                 <a:spcPts val="400"/>
               </a:spcAft>
             </a:pPr>
-            <a:endParaRPr sz="1100" b="0" i="0">
+            <a:endParaRPr sz="1400" b="0" i="0">
               <a:solidFill>
                 <a:srgbClr val="333333"/>
               </a:solidFill>
@@ -7260,7 +7320,7 @@
               </a:spcAft>
             </a:pPr>
             <a:r>
-              <a:rPr sz="1200" b="1" i="0">
+              <a:rPr sz="1600" b="1" i="0">
                 <a:solidFill>
                   <a:srgbClr val="CC0066"/>
                 </a:solidFill>
@@ -7276,7 +7336,7 @@
               </a:spcAft>
             </a:pPr>
             <a:r>
-              <a:rPr sz="1100" b="0" i="0">
+              <a:rPr sz="1400" b="0" i="0">
                 <a:solidFill>
                   <a:srgbClr val="333333"/>
                 </a:solidFill>
@@ -7292,7 +7352,7 @@
               </a:spcAft>
             </a:pPr>
             <a:r>
-              <a:rPr sz="1100" b="0" i="0">
+              <a:rPr sz="1400" b="0" i="0">
                 <a:solidFill>
                   <a:srgbClr val="333333"/>
                 </a:solidFill>
@@ -7308,7 +7368,7 @@
               </a:spcAft>
             </a:pPr>
             <a:r>
-              <a:rPr sz="1100" b="0" i="0">
+              <a:rPr sz="1400" b="0" i="0">
                 <a:solidFill>
                   <a:srgbClr val="333333"/>
                 </a:solidFill>
@@ -7324,7 +7384,7 @@
               </a:spcAft>
             </a:pPr>
             <a:r>
-              <a:rPr sz="1100" b="0" i="0">
+              <a:rPr sz="1400" b="0" i="0">
                 <a:solidFill>
                   <a:srgbClr val="333333"/>
                 </a:solidFill>
@@ -7339,7 +7399,7 @@
                 <a:spcPts val="400"/>
               </a:spcAft>
             </a:pPr>
-            <a:endParaRPr sz="1100" b="0" i="0">
+            <a:endParaRPr sz="1400" b="0" i="0">
               <a:solidFill>
                 <a:srgbClr val="333333"/>
               </a:solidFill>
@@ -7353,7 +7413,7 @@
               </a:spcAft>
             </a:pPr>
             <a:r>
-              <a:rPr sz="1100" b="0" i="0">
+              <a:rPr sz="1400" b="0" i="0">
                 <a:solidFill>
                   <a:srgbClr val="333333"/>
                 </a:solidFill>
@@ -7405,10 +7465,7 @@
           <a:lstStyle/>
           <a:p>
             <a:r>
-              <a:rPr sz="3200" b="1">
-                <a:solidFill>
-                  <a:srgbClr val="CC0066"/>
-                </a:solidFill>
+              <a:rPr sz="3200" b="1" dirty="0">
                 <a:latin typeface="Calibri"/>
               </a:rPr>
               <a:t>First-Boot Checklist</a:t>
@@ -7425,7 +7482,7 @@
         <p:spPr>
           <a:xfrm>
             <a:off x="822960" y="1417320"/>
-            <a:ext cx="10515600" cy="365760"/>
+            <a:ext cx="10515600" cy="338554"/>
           </a:xfrm>
           <a:prstGeom prst="rect">
             <a:avLst/>
@@ -7440,7 +7497,7 @@
           <a:p>
             <a:pPr algn="l"/>
             <a:r>
-              <a:rPr sz="1500" b="0" i="1">
+              <a:rPr sz="1600" b="0" i="1">
                 <a:solidFill>
                   <a:srgbClr val="666666"/>
                 </a:solidFill>
@@ -7551,8 +7608,8 @@
         </p:nvSpPr>
         <p:spPr>
           <a:xfrm>
-            <a:off x="1005840" y="1874519"/>
-            <a:ext cx="10241280" cy="4389120"/>
+            <a:off x="1197864" y="1714590"/>
+            <a:ext cx="10241280" cy="4708981"/>
           </a:xfrm>
           <a:prstGeom prst="rect">
             <a:avLst/>
@@ -7571,7 +7628,7 @@
               </a:spcAft>
             </a:pPr>
             <a:r>
-              <a:rPr sz="1100" i="1">
+              <a:rPr sz="1200" i="1">
                 <a:solidFill>
                   <a:srgbClr val="808080"/>
                 </a:solidFill>
@@ -7587,7 +7644,7 @@
               </a:spcAft>
             </a:pPr>
             <a:r>
-              <a:rPr sz="1100" i="1">
+              <a:rPr sz="1200" i="1">
                 <a:solidFill>
                   <a:srgbClr val="808080"/>
                 </a:solidFill>
@@ -7603,7 +7660,7 @@
               </a:spcAft>
             </a:pPr>
             <a:r>
-              <a:rPr sz="1100">
+              <a:rPr sz="1200">
                 <a:solidFill>
                   <a:srgbClr val="2D2D2D"/>
                 </a:solidFill>
@@ -7619,7 +7676,7 @@
               </a:spcAft>
             </a:pPr>
             <a:r>
-              <a:rPr sz="1100" i="1">
+              <a:rPr sz="1200" i="1">
                 <a:solidFill>
                   <a:srgbClr val="808080"/>
                 </a:solidFill>
@@ -7635,7 +7692,7 @@
               </a:spcAft>
             </a:pPr>
             <a:r>
-              <a:rPr sz="1100">
+              <a:rPr sz="1200">
                 <a:solidFill>
                   <a:srgbClr val="2D2D2D"/>
                 </a:solidFill>
@@ -7651,7 +7708,7 @@
               </a:spcAft>
             </a:pPr>
             <a:r>
-              <a:rPr sz="1100" i="1">
+              <a:rPr sz="1200" i="1">
                 <a:solidFill>
                   <a:srgbClr val="808080"/>
                 </a:solidFill>
@@ -7667,7 +7724,7 @@
               </a:spcAft>
             </a:pPr>
             <a:r>
-              <a:rPr sz="1100">
+              <a:rPr sz="1200">
                 <a:solidFill>
                   <a:srgbClr val="2D2D2D"/>
                 </a:solidFill>
@@ -7683,7 +7740,7 @@
               </a:spcAft>
             </a:pPr>
             <a:r>
-              <a:rPr sz="1100" i="1">
+              <a:rPr sz="1200" i="1">
                 <a:solidFill>
                   <a:srgbClr val="808080"/>
                 </a:solidFill>
@@ -7699,7 +7756,7 @@
               </a:spcAft>
             </a:pPr>
             <a:r>
-              <a:rPr sz="1100">
+              <a:rPr sz="1200">
                 <a:solidFill>
                   <a:srgbClr val="2D2D2D"/>
                 </a:solidFill>
@@ -7715,7 +7772,7 @@
               </a:spcAft>
             </a:pPr>
             <a:r>
-              <a:rPr sz="1100">
+              <a:rPr sz="1200">
                 <a:solidFill>
                   <a:srgbClr val="2D2D2D"/>
                 </a:solidFill>
@@ -7731,7 +7788,7 @@
               </a:spcAft>
             </a:pPr>
             <a:r>
-              <a:rPr sz="1100">
+              <a:rPr sz="1200">
                 <a:solidFill>
                   <a:srgbClr val="2D2D2D"/>
                 </a:solidFill>
@@ -7747,7 +7804,7 @@
               </a:spcAft>
             </a:pPr>
             <a:r>
-              <a:rPr sz="1100" i="1">
+              <a:rPr sz="1200" i="1">
                 <a:solidFill>
                   <a:srgbClr val="808080"/>
                 </a:solidFill>
@@ -7763,7 +7820,7 @@
               </a:spcAft>
             </a:pPr>
             <a:r>
-              <a:rPr sz="1100">
+              <a:rPr sz="1200">
                 <a:solidFill>
                   <a:srgbClr val="2D2D2D"/>
                 </a:solidFill>
@@ -7779,7 +7836,7 @@
               </a:spcAft>
             </a:pPr>
             <a:r>
-              <a:rPr sz="1100" i="1">
+              <a:rPr sz="1200" i="1">
                 <a:solidFill>
                   <a:srgbClr val="808080"/>
                 </a:solidFill>
@@ -7795,7 +7852,7 @@
               </a:spcAft>
             </a:pPr>
             <a:r>
-              <a:rPr sz="1100">
+              <a:rPr sz="1200">
                 <a:solidFill>
                   <a:srgbClr val="2D2D2D"/>
                 </a:solidFill>
@@ -7811,7 +7868,7 @@
               </a:spcAft>
             </a:pPr>
             <a:r>
-              <a:rPr sz="1100" i="1">
+              <a:rPr sz="1200" i="1">
                 <a:solidFill>
                   <a:srgbClr val="808080"/>
                 </a:solidFill>
@@ -7827,7 +7884,7 @@
               </a:spcAft>
             </a:pPr>
             <a:r>
-              <a:rPr sz="1100">
+              <a:rPr sz="1200">
                 <a:solidFill>
                   <a:srgbClr val="2D2D2D"/>
                 </a:solidFill>
@@ -7843,7 +7900,7 @@
               </a:spcAft>
             </a:pPr>
             <a:r>
-              <a:rPr sz="1100">
+              <a:rPr sz="1200">
                 <a:solidFill>
                   <a:srgbClr val="2D2D2D"/>
                 </a:solidFill>
@@ -7859,7 +7916,7 @@
               </a:spcAft>
             </a:pPr>
             <a:r>
-              <a:rPr sz="1100">
+              <a:rPr sz="1200">
                 <a:solidFill>
                   <a:srgbClr val="2D2D2D"/>
                 </a:solidFill>
@@ -7875,7 +7932,7 @@
               </a:spcAft>
             </a:pPr>
             <a:r>
-              <a:rPr sz="1100" i="1">
+              <a:rPr sz="1200" i="1">
                 <a:solidFill>
                   <a:srgbClr val="808080"/>
                 </a:solidFill>
@@ -7891,7 +7948,7 @@
               </a:spcAft>
             </a:pPr>
             <a:r>
-              <a:rPr sz="1100">
+              <a:rPr sz="1200">
                 <a:solidFill>
                   <a:srgbClr val="2D2D2D"/>
                 </a:solidFill>
@@ -7907,7 +7964,7 @@
               </a:spcAft>
             </a:pPr>
             <a:r>
-              <a:rPr sz="1100">
+              <a:rPr sz="1200">
                 <a:solidFill>
                   <a:srgbClr val="2D2D2D"/>
                 </a:solidFill>
@@ -7923,7 +7980,7 @@
               </a:spcAft>
             </a:pPr>
             <a:r>
-              <a:rPr sz="1100" i="1">
+              <a:rPr sz="1200" i="1">
                 <a:solidFill>
                   <a:srgbClr val="808080"/>
                 </a:solidFill>
@@ -7939,7 +7996,7 @@
               </a:spcAft>
             </a:pPr>
             <a:r>
-              <a:rPr sz="1100">
+              <a:rPr sz="1200">
                 <a:solidFill>
                   <a:srgbClr val="2D2D2D"/>
                 </a:solidFill>
@@ -7955,7 +8012,7 @@
               </a:spcAft>
             </a:pPr>
             <a:r>
-              <a:rPr sz="1100">
+              <a:rPr sz="1200">
                 <a:solidFill>
                   <a:srgbClr val="2D2D2D"/>
                 </a:solidFill>
@@ -8007,10 +8064,7 @@
           <a:lstStyle/>
           <a:p>
             <a:r>
-              <a:rPr sz="3200" b="1">
-                <a:solidFill>
-                  <a:srgbClr val="CC0066"/>
-                </a:solidFill>
+              <a:rPr sz="3200" b="1" dirty="0">
                 <a:latin typeface="Calibri"/>
               </a:rPr>
               <a:t>Common Bring-Up Failures</a:t>
@@ -8709,10 +8763,7 @@
           <a:lstStyle/>
           <a:p>
             <a:r>
-              <a:rPr sz="3200" b="1">
-                <a:solidFill>
-                  <a:srgbClr val="CC0066"/>
-                </a:solidFill>
+              <a:rPr sz="3200" b="1" dirty="0">
                 <a:latin typeface="Calibri"/>
               </a:rPr>
               <a:t>Validating a Clean Boot</a:t>
@@ -8855,8 +8906,8 @@
         </p:nvSpPr>
         <p:spPr>
           <a:xfrm>
-            <a:off x="1005840" y="1874519"/>
-            <a:ext cx="10241280" cy="4389120"/>
+            <a:off x="1271311" y="1783080"/>
+            <a:ext cx="10241280" cy="4693593"/>
           </a:xfrm>
           <a:prstGeom prst="rect">
             <a:avLst/>
@@ -8875,7 +8926,7 @@
               </a:spcAft>
             </a:pPr>
             <a:r>
-              <a:rPr sz="1100" i="1">
+              <a:rPr sz="1300" i="1">
                 <a:solidFill>
                   <a:srgbClr val="808080"/>
                 </a:solidFill>
@@ -8891,7 +8942,7 @@
               </a:spcAft>
             </a:pPr>
             <a:r>
-              <a:rPr sz="1100">
+              <a:rPr sz="1300">
                 <a:solidFill>
                   <a:srgbClr val="2D2D2D"/>
                 </a:solidFill>
@@ -8907,7 +8958,7 @@
               </a:spcAft>
             </a:pPr>
             <a:r>
-              <a:rPr sz="1100" i="1">
+              <a:rPr sz="1300" i="1">
                 <a:solidFill>
                   <a:srgbClr val="808080"/>
                 </a:solidFill>
@@ -8923,7 +8974,7 @@
               </a:spcAft>
             </a:pPr>
             <a:r>
-              <a:rPr sz="1100">
+              <a:rPr sz="1300">
                 <a:solidFill>
                   <a:srgbClr val="2D2D2D"/>
                 </a:solidFill>
@@ -8939,7 +8990,7 @@
               </a:spcAft>
             </a:pPr>
             <a:r>
-              <a:rPr sz="1100" i="1">
+              <a:rPr sz="1300" i="1">
                 <a:solidFill>
                   <a:srgbClr val="808080"/>
                 </a:solidFill>
@@ -8955,7 +9006,7 @@
               </a:spcAft>
             </a:pPr>
             <a:r>
-              <a:rPr sz="1100">
+              <a:rPr sz="1300">
                 <a:solidFill>
                   <a:srgbClr val="2D2D2D"/>
                 </a:solidFill>
@@ -8971,7 +9022,7 @@
               </a:spcAft>
             </a:pPr>
             <a:r>
-              <a:rPr sz="1100" i="1">
+              <a:rPr sz="1300" i="1">
                 <a:solidFill>
                   <a:srgbClr val="808080"/>
                 </a:solidFill>
@@ -8987,7 +9038,7 @@
               </a:spcAft>
             </a:pPr>
             <a:r>
-              <a:rPr sz="1100">
+              <a:rPr sz="1300">
                 <a:solidFill>
                   <a:srgbClr val="2D2D2D"/>
                 </a:solidFill>
@@ -9003,7 +9054,7 @@
               </a:spcAft>
             </a:pPr>
             <a:r>
-              <a:rPr sz="1100" i="1">
+              <a:rPr sz="1300" i="1">
                 <a:solidFill>
                   <a:srgbClr val="808080"/>
                 </a:solidFill>
@@ -9019,7 +9070,7 @@
               </a:spcAft>
             </a:pPr>
             <a:r>
-              <a:rPr sz="1100">
+              <a:rPr sz="1300">
                 <a:solidFill>
                   <a:srgbClr val="2D2D2D"/>
                 </a:solidFill>
@@ -9035,7 +9086,7 @@
               </a:spcAft>
             </a:pPr>
             <a:r>
-              <a:rPr sz="1100" i="1">
+              <a:rPr sz="1300" i="1">
                 <a:solidFill>
                   <a:srgbClr val="808080"/>
                 </a:solidFill>
@@ -9051,7 +9102,7 @@
               </a:spcAft>
             </a:pPr>
             <a:r>
-              <a:rPr sz="1100">
+              <a:rPr sz="1300">
                 <a:solidFill>
                   <a:srgbClr val="2D2D2D"/>
                 </a:solidFill>
@@ -9067,7 +9118,7 @@
               </a:spcAft>
             </a:pPr>
             <a:r>
-              <a:rPr sz="1100">
+              <a:rPr sz="1300">
                 <a:solidFill>
                   <a:srgbClr val="2D2D2D"/>
                 </a:solidFill>
@@ -9083,7 +9134,7 @@
               </a:spcAft>
             </a:pPr>
             <a:r>
-              <a:rPr sz="1100">
+              <a:rPr sz="1300">
                 <a:solidFill>
                   <a:srgbClr val="2D2D2D"/>
                 </a:solidFill>
@@ -9099,7 +9150,7 @@
               </a:spcAft>
             </a:pPr>
             <a:r>
-              <a:rPr sz="1100" i="1">
+              <a:rPr sz="1300" i="1">
                 <a:solidFill>
                   <a:srgbClr val="808080"/>
                 </a:solidFill>
@@ -9115,7 +9166,7 @@
               </a:spcAft>
             </a:pPr>
             <a:r>
-              <a:rPr sz="1100">
+              <a:rPr sz="1300">
                 <a:solidFill>
                   <a:srgbClr val="2D2D2D"/>
                 </a:solidFill>
@@ -9131,7 +9182,7 @@
               </a:spcAft>
             </a:pPr>
             <a:r>
-              <a:rPr sz="1100">
+              <a:rPr sz="1300">
                 <a:solidFill>
                   <a:srgbClr val="2D2D2D"/>
                 </a:solidFill>
@@ -9147,7 +9198,7 @@
               </a:spcAft>
             </a:pPr>
             <a:r>
-              <a:rPr sz="1100" i="1">
+              <a:rPr sz="1300" i="1">
                 <a:solidFill>
                   <a:srgbClr val="808080"/>
                 </a:solidFill>
@@ -9163,7 +9214,7 @@
               </a:spcAft>
             </a:pPr>
             <a:r>
-              <a:rPr sz="1100">
+              <a:rPr sz="1300">
                 <a:solidFill>
                   <a:srgbClr val="2D2D2D"/>
                 </a:solidFill>
@@ -9179,7 +9230,7 @@
               </a:spcAft>
             </a:pPr>
             <a:r>
-              <a:rPr sz="1100">
+              <a:rPr sz="1300">
                 <a:solidFill>
                   <a:srgbClr val="2D2D2D"/>
                 </a:solidFill>
@@ -9195,7 +9246,7 @@
               </a:spcAft>
             </a:pPr>
             <a:r>
-              <a:rPr sz="1100">
+              <a:rPr sz="1300">
                 <a:solidFill>
                   <a:srgbClr val="2D2D2D"/>
                 </a:solidFill>
@@ -9211,7 +9262,7 @@
               </a:spcAft>
             </a:pPr>
             <a:r>
-              <a:rPr sz="1100" i="1">
+              <a:rPr sz="1300" i="1">
                 <a:solidFill>
                   <a:srgbClr val="808080"/>
                 </a:solidFill>
@@ -9227,7 +9278,7 @@
               </a:spcAft>
             </a:pPr>
             <a:r>
-              <a:rPr sz="1100">
+              <a:rPr sz="1300">
                 <a:solidFill>
                   <a:srgbClr val="2D2D2D"/>
                 </a:solidFill>
@@ -9279,10 +9330,7 @@
           <a:lstStyle/>
           <a:p>
             <a:r>
-              <a:rPr sz="3200" b="1">
-                <a:solidFill>
-                  <a:srgbClr val="663399"/>
-                </a:solidFill>
+              <a:rPr sz="3200" b="1" dirty="0">
                 <a:latin typeface="Calibri"/>
               </a:rPr>
               <a:t>Session Summary</a:t>
@@ -9997,7 +10045,7 @@
                 </a:solidFill>
                 <a:latin typeface="Calibri"/>
               </a:rPr>
-              <a:t>Day-to-day operations (105 min)</a:t>
+              <a:t>Day-to-day operations </a:t>
             </a:r>
           </a:p>
         </p:txBody>

</xml_diff>